<commit_message>
cleaned up unneeded files
</commit_message>
<xml_diff>
--- a/lectures/NXS_Intro_2026.pptx
+++ b/lectures/NXS_Intro_2026.pptx
@@ -230,7 +230,7 @@
           <a:p>
             <a:fld id="{DA614C3F-0AF5-DA4C-84F9-3990FF0B58A5}" type="datetimeFigureOut">
               <a:rPr lang="en-US" smtClean="0"/>
-              <a:t>8/25/26</a:t>
+              <a:t>8/28/26</a:t>
             </a:fld>
             <a:endParaRPr lang="en-US"/>
           </a:p>
@@ -407,7 +407,7 @@
           <a:p>
             <a:fld id="{9F2D4C33-E834-184F-A85B-4B1A7D742F82}" type="datetimeFigureOut">
               <a:rPr lang="en-US" smtClean="0"/>
-              <a:t>8/25/26</a:t>
+              <a:t>8/28/26</a:t>
             </a:fld>
             <a:endParaRPr lang="en-US"/>
           </a:p>
@@ -4768,8 +4768,8 @@
         </p:blipFill>
         <p:spPr>
           <a:xfrm>
-            <a:off x="8070574" y="3855342"/>
-            <a:ext cx="3605696" cy="1961257"/>
+            <a:off x="7975033" y="3803374"/>
+            <a:ext cx="3701237" cy="2013225"/>
           </a:xfrm>
           <a:prstGeom prst="rect">
             <a:avLst/>

</xml_diff>